<commit_message>
Remove slide numbers from project 14 (smart-parking) deck; Ebin's ski deck (25) sidebar number left intact
</commit_message>
<xml_diff>
--- a/ppt/smart-parking-management.pptx
+++ b/ppt/smart-parking-management.pptx
@@ -3546,41 +3546,6 @@
       </p:sp>
       <p:sp>
         <p:nvSpPr>
-          <p:cNvPr id="5" name="TextBox 4"/>
-          <p:cNvSpPr txBox="1"/>
-          <p:nvPr/>
-        </p:nvSpPr>
-        <p:spPr>
-          <a:xfrm>
-            <a:off x="11140135" y="320040"/>
-            <a:ext cx="1051560" cy="914400"/>
-          </a:xfrm>
-          <a:prstGeom prst="rect">
-            <a:avLst/>
-          </a:prstGeom>
-          <a:noFill/>
-        </p:spPr>
-        <p:txBody>
-          <a:bodyPr wrap="square" anchor="t">
-            <a:spAutoFit/>
-          </a:bodyPr>
-          <a:lstStyle/>
-          <a:p>
-            <a:pPr algn="ctr"/>
-            <a:r>
-              <a:rPr sz="2600" b="1" i="0">
-                <a:solidFill>
-                  <a:srgbClr val="FFFFFF"/>
-                </a:solidFill>
-                <a:latin typeface="Tahoma"/>
-              </a:rPr>
-              <a:t>1</a:t>
-            </a:r>
-          </a:p>
-        </p:txBody>
-      </p:sp>
-      <p:sp>
-        <p:nvSpPr>
           <p:cNvPr id="6" name="Rectangle 5"/>
           <p:cNvSpPr/>
           <p:nvPr/>
@@ -3887,41 +3852,6 @@
       </p:sp>
       <p:sp>
         <p:nvSpPr>
-          <p:cNvPr id="5" name="TextBox 4"/>
-          <p:cNvSpPr txBox="1"/>
-          <p:nvPr/>
-        </p:nvSpPr>
-        <p:spPr>
-          <a:xfrm>
-            <a:off x="11140135" y="320040"/>
-            <a:ext cx="1051560" cy="914400"/>
-          </a:xfrm>
-          <a:prstGeom prst="rect">
-            <a:avLst/>
-          </a:prstGeom>
-          <a:noFill/>
-        </p:spPr>
-        <p:txBody>
-          <a:bodyPr wrap="square" anchor="t">
-            <a:spAutoFit/>
-          </a:bodyPr>
-          <a:lstStyle/>
-          <a:p>
-            <a:pPr algn="ctr"/>
-            <a:r>
-              <a:rPr sz="2600" b="1" i="0">
-                <a:solidFill>
-                  <a:srgbClr val="FFFFFF"/>
-                </a:solidFill>
-                <a:latin typeface="Tahoma"/>
-              </a:rPr>
-              <a:t>2</a:t>
-            </a:r>
-          </a:p>
-        </p:txBody>
-      </p:sp>
-      <p:sp>
-        <p:nvSpPr>
           <p:cNvPr id="6" name="Rectangle 5"/>
           <p:cNvSpPr/>
           <p:nvPr/>
@@ -4159,41 +4089,6 @@
           <a:lstStyle/>
           <a:p>
             <a:pPr algn="ctr"/>
-          </a:p>
-        </p:txBody>
-      </p:sp>
-      <p:sp>
-        <p:nvSpPr>
-          <p:cNvPr id="5" name="TextBox 4"/>
-          <p:cNvSpPr txBox="1"/>
-          <p:nvPr/>
-        </p:nvSpPr>
-        <p:spPr>
-          <a:xfrm>
-            <a:off x="11140135" y="320040"/>
-            <a:ext cx="1051560" cy="914400"/>
-          </a:xfrm>
-          <a:prstGeom prst="rect">
-            <a:avLst/>
-          </a:prstGeom>
-          <a:noFill/>
-        </p:spPr>
-        <p:txBody>
-          <a:bodyPr wrap="square" anchor="t">
-            <a:spAutoFit/>
-          </a:bodyPr>
-          <a:lstStyle/>
-          <a:p>
-            <a:pPr algn="ctr"/>
-            <a:r>
-              <a:rPr sz="2600" b="1" i="0">
-                <a:solidFill>
-                  <a:srgbClr val="FFFFFF"/>
-                </a:solidFill>
-                <a:latin typeface="Tahoma"/>
-              </a:rPr>
-              <a:t>3</a:t>
-            </a:r>
           </a:p>
         </p:txBody>
       </p:sp>
@@ -4545,41 +4440,6 @@
       </p:sp>
       <p:sp>
         <p:nvSpPr>
-          <p:cNvPr id="5" name="TextBox 4"/>
-          <p:cNvSpPr txBox="1"/>
-          <p:nvPr/>
-        </p:nvSpPr>
-        <p:spPr>
-          <a:xfrm>
-            <a:off x="11140135" y="320040"/>
-            <a:ext cx="1051560" cy="914400"/>
-          </a:xfrm>
-          <a:prstGeom prst="rect">
-            <a:avLst/>
-          </a:prstGeom>
-          <a:noFill/>
-        </p:spPr>
-        <p:txBody>
-          <a:bodyPr wrap="square" anchor="t">
-            <a:spAutoFit/>
-          </a:bodyPr>
-          <a:lstStyle/>
-          <a:p>
-            <a:pPr algn="ctr"/>
-            <a:r>
-              <a:rPr sz="2600" b="1" i="0">
-                <a:solidFill>
-                  <a:srgbClr val="FFFFFF"/>
-                </a:solidFill>
-                <a:latin typeface="Tahoma"/>
-              </a:rPr>
-              <a:t>4</a:t>
-            </a:r>
-          </a:p>
-        </p:txBody>
-      </p:sp>
-      <p:sp>
-        <p:nvSpPr>
           <p:cNvPr id="6" name="Rectangle 5"/>
           <p:cNvSpPr/>
           <p:nvPr/>
@@ -4849,41 +4709,6 @@
           <a:lstStyle/>
           <a:p>
             <a:pPr algn="ctr"/>
-          </a:p>
-        </p:txBody>
-      </p:sp>
-      <p:sp>
-        <p:nvSpPr>
-          <p:cNvPr id="5" name="TextBox 4"/>
-          <p:cNvSpPr txBox="1"/>
-          <p:nvPr/>
-        </p:nvSpPr>
-        <p:spPr>
-          <a:xfrm>
-            <a:off x="11140135" y="320040"/>
-            <a:ext cx="1051560" cy="914400"/>
-          </a:xfrm>
-          <a:prstGeom prst="rect">
-            <a:avLst/>
-          </a:prstGeom>
-          <a:noFill/>
-        </p:spPr>
-        <p:txBody>
-          <a:bodyPr wrap="square" anchor="t">
-            <a:spAutoFit/>
-          </a:bodyPr>
-          <a:lstStyle/>
-          <a:p>
-            <a:pPr algn="ctr"/>
-            <a:r>
-              <a:rPr sz="2600" b="1" i="0">
-                <a:solidFill>
-                  <a:srgbClr val="FFFFFF"/>
-                </a:solidFill>
-                <a:latin typeface="Tahoma"/>
-              </a:rPr>
-              <a:t>5</a:t>
-            </a:r>
           </a:p>
         </p:txBody>
       </p:sp>

</xml_diff>